<commit_message>
Project complete: validation report, README, decision 32, presentation
</commit_message>
<xml_diff>
--- a/docs/Calendly_Marketing_Insights_Presentation.pptx
+++ b/docs/Calendly_Marketing_Insights_Presentation.pptx
@@ -114,20 +114,20 @@
   <p:extLst>
     <p:ext uri="{521415D9-36F7-43E2-AB2F-B90AF26B5E84}">
       <p14:sectionLst xmlns:p14="http://schemas.microsoft.com/office/powerpoint/2010/main">
-        <p14:section name="Overview" id="{b1579216-1860-8c7e-eb1f-cdbf002af5b9}">
+        <p14:section name="Overview" id="{47704329-d791-2f10-ec62-0a5f13656f94}">
           <p14:sldIdLst>
             <p14:sldId id="256"/>
             <p14:sldId id="257"/>
           </p14:sldIdLst>
         </p14:section>
-        <p14:section name="Design" id="{2568100c-5383-d5ff-d78f-ff6df3ae5d66}">
+        <p14:section name="Design" id="{2da9a3aa-3cfb-046e-be3e-6c80dc6d38de}">
           <p14:sldIdLst>
             <p14:sldId id="258"/>
             <p14:sldId id="259"/>
             <p14:sldId id="260"/>
           </p14:sldIdLst>
         </p14:section>
-        <p14:section name="Results" id="{d94997b7-7cff-71c2-faf4-be27ef134f60}">
+        <p14:section name="Results" id="{0c28ef59-36f6-5780-fd37-a3a69c09ea27}">
           <p14:sldIdLst>
             <p14:sldId id="261"/>
             <p14:sldId id="262"/>
@@ -169,7 +169,7 @@
                 </a:solidFill>
                 <a:latin typeface="+mn-lt"/>
               </a:rPr>
-              <a:t>Spend by channel, USD, 60 days to 27 October</a:t>
+              <a:t>Spend by channel, USD, 63 days to 30 October</a:t>
             </a:r>
           </a:p>
         </c:rich>
@@ -255,13 +255,13 @@
                 <c:formatCode>General</c:formatCode>
                 <c:ptCount val="3"/>
                 <c:pt idx="0">
-                  <c:v>37967.04</c:v>
+                  <c:v>40434.58</c:v>
                 </c:pt>
                 <c:pt idx="1">
-                  <c:v>35636.89</c:v>
+                  <c:v>37758.42</c:v>
                 </c:pt>
                 <c:pt idx="2">
-                  <c:v>23664.39</c:v>
+                  <c:v>24864.86</c:v>
                 </c:pt>
               </c:numCache>
             </c:numRef>
@@ -4781,7 +4781,7 @@
                   <a:schemeClr val="tx2"/>
                 </a:solidFill>
               </a:rPr>
-              <a:t>Live since 28 October</a:t>
+              <a:t>Live traffic, validated 31 October</a:t>
             </a:r>
             <a:endParaRPr lang="en-US" sz="3000" dirty="0"/>
           </a:p>
@@ -4844,7 +4844,7 @@
                   <a:schemeClr val="tx2"/>
                 </a:solidFill>
               </a:rPr>
-              <a:t>31</a:t>
+              <a:t>119</a:t>
             </a:r>
             <a:endParaRPr lang="en-US" sz="4000" dirty="0"/>
           </a:p>
@@ -4880,7 +4880,7 @@
                   <a:schemeClr val="tx1"/>
                 </a:solidFill>
               </a:rPr>
-              <a:t>spend files ingested,</a:t>
+              <a:t>live events landed</a:t>
             </a:r>
             <a:endParaRPr lang="en-US" sz="1200" dirty="0"/>
           </a:p>
@@ -4894,7 +4894,7 @@
                   <a:schemeClr val="tx1"/>
                 </a:solidFill>
               </a:rPr>
-              <a:t>no manual steps</a:t>
+              <a:t>on the first day</a:t>
             </a:r>
             <a:endParaRPr lang="en-US" sz="1200" dirty="0"/>
           </a:p>
@@ -4957,7 +4957,7 @@
                   <a:schemeClr val="tx2"/>
                 </a:solidFill>
               </a:rPr>
-              <a:t>$97,268</a:t>
+              <a:t>11</a:t>
             </a:r>
             <a:endParaRPr lang="en-US" sz="4000" dirty="0"/>
           </a:p>
@@ -4993,7 +4993,7 @@
                   <a:schemeClr val="tx1"/>
                 </a:solidFill>
               </a:rPr>
-              <a:t>spend loaded,</a:t>
+              <a:t>campaign bookings;</a:t>
             </a:r>
             <a:endParaRPr lang="en-US" sz="1200" dirty="0"/>
           </a:p>
@@ -5007,7 +5007,7 @@
                   <a:schemeClr val="tx1"/>
                 </a:solidFill>
               </a:rPr>
-              <a:t>29 Aug to 27 Oct</a:t>
+              <a:t>CPB $4,720 FB, $8,288 TikTok</a:t>
             </a:r>
             <a:endParaRPr lang="en-US" sz="1200" dirty="0"/>
           </a:p>
@@ -5070,7 +5070,7 @@
                   <a:schemeClr val="tx2"/>
                 </a:solidFill>
               </a:rPr>
-              <a:t>2 min</a:t>
+              <a:t>$103K</a:t>
             </a:r>
             <a:endParaRPr lang="en-US" sz="4000" dirty="0"/>
           </a:p>
@@ -5106,7 +5106,7 @@
                   <a:schemeClr val="tx1"/>
                 </a:solidFill>
               </a:rPr>
-              <a:t>hourly job,</a:t>
+              <a:t>spend loaded, 63 days,</a:t>
             </a:r>
             <a:endParaRPr lang="en-US" sz="1200" dirty="0"/>
           </a:p>
@@ -5120,7 +5120,7 @@
                   <a:schemeClr val="tx1"/>
                 </a:solidFill>
               </a:rPr>
-              <a:t>all three layers</a:t>
+              <a:t>no manual steps</a:t>
             </a:r>
             <a:endParaRPr lang="en-US" sz="1200" dirty="0"/>
           </a:p>
@@ -5183,7 +5183,7 @@
                   <a:schemeClr val="tx2"/>
                 </a:solidFill>
               </a:rPr>
-              <a:t>7 / 7</a:t>
+              <a:t>9 / 9</a:t>
             </a:r>
             <a:endParaRPr lang="en-US" sz="4000" dirty="0"/>
           </a:p>
@@ -5861,7 +5861,7 @@
                   <a:schemeClr val="bg1"/>
                 </a:solidFill>
               </a:rPr>
-              <a:t>Validation window</a:t>
+              <a:t>Validation complete</a:t>
             </a:r>
             <a:endParaRPr lang="en-US" sz="4000" dirty="0"/>
           </a:p>
@@ -5899,7 +5899,7 @@
                   <a:schemeClr val="bg2"/>
                 </a:solidFill>
               </a:rPr>
-              <a:t>Endpoint shared with the program on 27 October; awaiting the webhook subscription and signing key. Then: enable signature verification, remove test events, confirm live bookings flow to Silver within the hour, and report CPB by channel.</a:t>
+              <a:t>Subscription active 30 October; signing key received and verification enabled 31 October; signed deliveries accepted; live bookings on the dashboard within the hour; CPB by channel computed. Report: docs/final_report.md.</a:t>
             </a:r>
             <a:endParaRPr lang="en-US" sz="1800" dirty="0"/>
           </a:p>

</xml_diff>